<commit_message>
Balance margins and drop the U+2212 minus from the Kluber deck
The right column sat 0.33in from the edge against a 0.55in left margin;
column width and origin now give equal margins on both sides. Slide 2s
left column lost an empty band between the definition block and the
thickener table.

Temperatures used U+2212 MINUS SIGN, which not every installed font
carries -- replaced with ASCII hyphen so -60 and -30 render everywhere.

Verified by rendering each slide from its shape geometry, since this
environments LibreOffice has no Impress filter and cannot open pptx at
all (the original file fails the same way).

Co-Authored-By: Claude Opus 5 <noreply@anthropic.com>
Claude-Session: https://claude.ai/code/session_01UEsLPMwF69aavPNwWVFuSY
</commit_message>
<xml_diff>
--- a/Kluber_EAL_Grease_simple.pptx
+++ b/Kluber_EAL_Grease_simple.pptx
@@ -5848,7 +5848,7 @@
         <p:spPr>
           <a:xfrm>
             <a:off x="502920" y="1325880"/>
-            <a:ext cx="5532120" cy="329184"/>
+            <a:ext cx="5440680" cy="329184"/>
           </a:xfrm>
           <a:prstGeom prst="rect">
             <a:avLst/>
@@ -5892,7 +5892,7 @@
         <p:spPr>
           <a:xfrm>
             <a:off x="612648" y="1325880"/>
-            <a:ext cx="5349240" cy="329184"/>
+            <a:ext cx="5257800" cy="329184"/>
           </a:xfrm>
           <a:prstGeom prst="rect">
             <a:avLst/>
@@ -5933,7 +5933,7 @@
         <p:spPr>
           <a:xfrm>
             <a:off x="502920" y="1783080"/>
-            <a:ext cx="5532120" cy="1463040"/>
+            <a:ext cx="5440680" cy="1463040"/>
           </a:xfrm>
           <a:prstGeom prst="rect">
             <a:avLst/>
@@ -6015,8 +6015,8 @@
         </p:nvSpPr>
         <p:spPr>
           <a:xfrm>
-            <a:off x="502920" y="3383280"/>
-            <a:ext cx="5532120" cy="329184"/>
+            <a:off x="502920" y="3017520"/>
+            <a:ext cx="5440680" cy="329184"/>
           </a:xfrm>
           <a:prstGeom prst="rect">
             <a:avLst/>
@@ -6059,8 +6059,8 @@
         </p:nvSpPr>
         <p:spPr>
           <a:xfrm>
-            <a:off x="612648" y="3383280"/>
-            <a:ext cx="5349240" cy="329184"/>
+            <a:off x="612648" y="3017520"/>
+            <a:ext cx="5257800" cy="329184"/>
           </a:xfrm>
           <a:prstGeom prst="rect">
             <a:avLst/>
@@ -6100,8 +6100,8 @@
         </p:nvSpPr>
         <p:spPr>
           <a:xfrm>
-            <a:off x="502920" y="3840480"/>
-            <a:ext cx="2697480" cy="310896"/>
+            <a:off x="502920" y="3474720"/>
+            <a:ext cx="2651760" cy="310896"/>
           </a:xfrm>
           <a:prstGeom prst="rect">
             <a:avLst/>
@@ -6144,8 +6144,8 @@
         </p:nvSpPr>
         <p:spPr>
           <a:xfrm>
-            <a:off x="576072" y="3840480"/>
-            <a:ext cx="2551176" cy="310896"/>
+            <a:off x="576072" y="3474720"/>
+            <a:ext cx="2505456" cy="310896"/>
           </a:xfrm>
           <a:prstGeom prst="rect">
             <a:avLst/>
@@ -6185,7 +6185,7 @@
         </p:nvSpPr>
         <p:spPr>
           <a:xfrm>
-            <a:off x="3200400" y="3840480"/>
+            <a:off x="3154680" y="3474720"/>
             <a:ext cx="1234440" cy="310896"/>
           </a:xfrm>
           <a:prstGeom prst="rect">
@@ -6229,7 +6229,7 @@
         </p:nvSpPr>
         <p:spPr>
           <a:xfrm>
-            <a:off x="3273552" y="3840480"/>
+            <a:off x="3227832" y="3474720"/>
             <a:ext cx="1088136" cy="310896"/>
           </a:xfrm>
           <a:prstGeom prst="rect">
@@ -6270,8 +6270,8 @@
         </p:nvSpPr>
         <p:spPr>
           <a:xfrm>
-            <a:off x="4434840" y="3840480"/>
-            <a:ext cx="1600200" cy="310896"/>
+            <a:off x="4389120" y="3474720"/>
+            <a:ext cx="1554480" cy="310896"/>
           </a:xfrm>
           <a:prstGeom prst="rect">
             <a:avLst/>
@@ -6314,8 +6314,8 @@
         </p:nvSpPr>
         <p:spPr>
           <a:xfrm>
-            <a:off x="4507992" y="3840480"/>
-            <a:ext cx="1453896" cy="310896"/>
+            <a:off x="4462272" y="3474720"/>
+            <a:ext cx="1408176" cy="310896"/>
           </a:xfrm>
           <a:prstGeom prst="rect">
             <a:avLst/>
@@ -6355,8 +6355,8 @@
         </p:nvSpPr>
         <p:spPr>
           <a:xfrm>
-            <a:off x="502920" y="4151376"/>
-            <a:ext cx="2697480" cy="310896"/>
+            <a:off x="502920" y="3785616"/>
+            <a:ext cx="2651760" cy="310896"/>
           </a:xfrm>
           <a:prstGeom prst="rect">
             <a:avLst/>
@@ -6401,8 +6401,8 @@
         </p:nvSpPr>
         <p:spPr>
           <a:xfrm>
-            <a:off x="576072" y="4151376"/>
-            <a:ext cx="2551176" cy="310896"/>
+            <a:off x="576072" y="3785616"/>
+            <a:ext cx="2505456" cy="310896"/>
           </a:xfrm>
           <a:prstGeom prst="rect">
             <a:avLst/>
@@ -6442,7 +6442,7 @@
         </p:nvSpPr>
         <p:spPr>
           <a:xfrm>
-            <a:off x="3200400" y="4151376"/>
+            <a:off x="3154680" y="3785616"/>
             <a:ext cx="1234440" cy="310896"/>
           </a:xfrm>
           <a:prstGeom prst="rect">
@@ -6488,7 +6488,7 @@
         </p:nvSpPr>
         <p:spPr>
           <a:xfrm>
-            <a:off x="3273552" y="4151376"/>
+            <a:off x="3227832" y="3785616"/>
             <a:ext cx="1088136" cy="310896"/>
           </a:xfrm>
           <a:prstGeom prst="rect">
@@ -6529,8 +6529,8 @@
         </p:nvSpPr>
         <p:spPr>
           <a:xfrm>
-            <a:off x="4434840" y="4151376"/>
-            <a:ext cx="1600200" cy="310896"/>
+            <a:off x="4389120" y="3785616"/>
+            <a:ext cx="1554480" cy="310896"/>
           </a:xfrm>
           <a:prstGeom prst="rect">
             <a:avLst/>
@@ -6575,8 +6575,8 @@
         </p:nvSpPr>
         <p:spPr>
           <a:xfrm>
-            <a:off x="4507992" y="4151376"/>
-            <a:ext cx="1453896" cy="310896"/>
+            <a:off x="4462272" y="3785616"/>
+            <a:ext cx="1408176" cy="310896"/>
           </a:xfrm>
           <a:prstGeom prst="rect">
             <a:avLst/>
@@ -6616,8 +6616,8 @@
         </p:nvSpPr>
         <p:spPr>
           <a:xfrm>
-            <a:off x="502920" y="4462272"/>
-            <a:ext cx="2697480" cy="310896"/>
+            <a:off x="502920" y="4096512"/>
+            <a:ext cx="2651760" cy="310896"/>
           </a:xfrm>
           <a:prstGeom prst="rect">
             <a:avLst/>
@@ -6662,8 +6662,8 @@
         </p:nvSpPr>
         <p:spPr>
           <a:xfrm>
-            <a:off x="576072" y="4462272"/>
-            <a:ext cx="2551176" cy="310896"/>
+            <a:off x="576072" y="4096512"/>
+            <a:ext cx="2505456" cy="310896"/>
           </a:xfrm>
           <a:prstGeom prst="rect">
             <a:avLst/>
@@ -6703,7 +6703,7 @@
         </p:nvSpPr>
         <p:spPr>
           <a:xfrm>
-            <a:off x="3200400" y="4462272"/>
+            <a:off x="3154680" y="4096512"/>
             <a:ext cx="1234440" cy="310896"/>
           </a:xfrm>
           <a:prstGeom prst="rect">
@@ -6749,7 +6749,7 @@
         </p:nvSpPr>
         <p:spPr>
           <a:xfrm>
-            <a:off x="3273552" y="4462272"/>
+            <a:off x="3227832" y="4096512"/>
             <a:ext cx="1088136" cy="310896"/>
           </a:xfrm>
           <a:prstGeom prst="rect">
@@ -6790,8 +6790,8 @@
         </p:nvSpPr>
         <p:spPr>
           <a:xfrm>
-            <a:off x="4434840" y="4462272"/>
-            <a:ext cx="1600200" cy="310896"/>
+            <a:off x="4389120" y="4096512"/>
+            <a:ext cx="1554480" cy="310896"/>
           </a:xfrm>
           <a:prstGeom prst="rect">
             <a:avLst/>
@@ -6836,8 +6836,8 @@
         </p:nvSpPr>
         <p:spPr>
           <a:xfrm>
-            <a:off x="4507992" y="4462272"/>
-            <a:ext cx="1453896" cy="310896"/>
+            <a:off x="4462272" y="4096512"/>
+            <a:ext cx="1408176" cy="310896"/>
           </a:xfrm>
           <a:prstGeom prst="rect">
             <a:avLst/>
@@ -6877,8 +6877,8 @@
         </p:nvSpPr>
         <p:spPr>
           <a:xfrm>
-            <a:off x="502920" y="4773168"/>
-            <a:ext cx="2697480" cy="310896"/>
+            <a:off x="502920" y="4407408"/>
+            <a:ext cx="2651760" cy="310896"/>
           </a:xfrm>
           <a:prstGeom prst="rect">
             <a:avLst/>
@@ -6923,8 +6923,8 @@
         </p:nvSpPr>
         <p:spPr>
           <a:xfrm>
-            <a:off x="576072" y="4773168"/>
-            <a:ext cx="2551176" cy="310896"/>
+            <a:off x="576072" y="4407408"/>
+            <a:ext cx="2505456" cy="310896"/>
           </a:xfrm>
           <a:prstGeom prst="rect">
             <a:avLst/>
@@ -6964,7 +6964,7 @@
         </p:nvSpPr>
         <p:spPr>
           <a:xfrm>
-            <a:off x="3200400" y="4773168"/>
+            <a:off x="3154680" y="4407408"/>
             <a:ext cx="1234440" cy="310896"/>
           </a:xfrm>
           <a:prstGeom prst="rect">
@@ -7010,7 +7010,7 @@
         </p:nvSpPr>
         <p:spPr>
           <a:xfrm>
-            <a:off x="3273552" y="4773168"/>
+            <a:off x="3227832" y="4407408"/>
             <a:ext cx="1088136" cy="310896"/>
           </a:xfrm>
           <a:prstGeom prst="rect">
@@ -7051,8 +7051,8 @@
         </p:nvSpPr>
         <p:spPr>
           <a:xfrm>
-            <a:off x="4434840" y="4773168"/>
-            <a:ext cx="1600200" cy="310896"/>
+            <a:off x="4389120" y="4407408"/>
+            <a:ext cx="1554480" cy="310896"/>
           </a:xfrm>
           <a:prstGeom prst="rect">
             <a:avLst/>
@@ -7097,8 +7097,8 @@
         </p:nvSpPr>
         <p:spPr>
           <a:xfrm>
-            <a:off x="4507992" y="4773168"/>
-            <a:ext cx="1453896" cy="310896"/>
+            <a:off x="4462272" y="4407408"/>
+            <a:ext cx="1408176" cy="310896"/>
           </a:xfrm>
           <a:prstGeom prst="rect">
             <a:avLst/>
@@ -7138,8 +7138,8 @@
         </p:nvSpPr>
         <p:spPr>
           <a:xfrm>
-            <a:off x="6355080" y="1325880"/>
-            <a:ext cx="5532120" cy="329184"/>
+            <a:off x="6245352" y="1325880"/>
+            <a:ext cx="5440680" cy="329184"/>
           </a:xfrm>
           <a:prstGeom prst="rect">
             <a:avLst/>
@@ -7182,8 +7182,8 @@
         </p:nvSpPr>
         <p:spPr>
           <a:xfrm>
-            <a:off x="6464808" y="1325880"/>
-            <a:ext cx="5349240" cy="329184"/>
+            <a:off x="6355080" y="1325880"/>
+            <a:ext cx="5257800" cy="329184"/>
           </a:xfrm>
           <a:prstGeom prst="rect">
             <a:avLst/>
@@ -7223,8 +7223,8 @@
         </p:nvSpPr>
         <p:spPr>
           <a:xfrm>
-            <a:off x="6355080" y="1783080"/>
-            <a:ext cx="5532120" cy="1371600"/>
+            <a:off x="6245352" y="1783080"/>
+            <a:ext cx="5440680" cy="1371600"/>
           </a:xfrm>
           <a:prstGeom prst="rect">
             <a:avLst/>
@@ -7267,8 +7267,8 @@
         </p:nvSpPr>
         <p:spPr>
           <a:xfrm>
-            <a:off x="6355080" y="1911096"/>
-            <a:ext cx="5532120" cy="1143000"/>
+            <a:off x="6245352" y="1911096"/>
+            <a:ext cx="5440680" cy="1143000"/>
           </a:xfrm>
           <a:prstGeom prst="rect">
             <a:avLst/>
@@ -7326,8 +7326,8 @@
         </p:nvSpPr>
         <p:spPr>
           <a:xfrm>
-            <a:off x="6355080" y="3319272"/>
-            <a:ext cx="5532120" cy="822960"/>
+            <a:off x="6245352" y="3319272"/>
+            <a:ext cx="5440680" cy="822960"/>
           </a:xfrm>
           <a:prstGeom prst="rect">
             <a:avLst/>
@@ -7396,7 +7396,7 @@
         </p:blipFill>
         <p:spPr>
           <a:xfrm>
-            <a:off x="8321040" y="4233672"/>
+            <a:off x="8211312" y="4233672"/>
             <a:ext cx="1743162" cy="1691640"/>
           </a:xfrm>
           <a:prstGeom prst="rect">
@@ -7412,8 +7412,8 @@
         </p:nvSpPr>
         <p:spPr>
           <a:xfrm>
-            <a:off x="6355080" y="6016752"/>
-            <a:ext cx="5532120" cy="274320"/>
+            <a:off x="6245352" y="6016752"/>
+            <a:ext cx="5440680" cy="274320"/>
           </a:xfrm>
           <a:prstGeom prst="rect">
             <a:avLst/>
@@ -7598,7 +7598,7 @@
         <p:spPr>
           <a:xfrm>
             <a:off x="502920" y="1325880"/>
-            <a:ext cx="5532120" cy="329184"/>
+            <a:ext cx="5440680" cy="329184"/>
           </a:xfrm>
           <a:prstGeom prst="rect">
             <a:avLst/>
@@ -7642,7 +7642,7 @@
         <p:spPr>
           <a:xfrm>
             <a:off x="612648" y="1325880"/>
-            <a:ext cx="5349240" cy="329184"/>
+            <a:ext cx="5257800" cy="329184"/>
           </a:xfrm>
           <a:prstGeom prst="rect">
             <a:avLst/>
@@ -7707,7 +7707,7 @@
         <p:spPr>
           <a:xfrm>
             <a:off x="502920" y="3657599"/>
-            <a:ext cx="5532120" cy="274320"/>
+            <a:ext cx="5440680" cy="274320"/>
           </a:xfrm>
           <a:prstGeom prst="rect">
             <a:avLst/>
@@ -7748,7 +7748,7 @@
         <p:spPr>
           <a:xfrm>
             <a:off x="502920" y="4069080"/>
-            <a:ext cx="5532120" cy="329184"/>
+            <a:ext cx="5440680" cy="329184"/>
           </a:xfrm>
           <a:prstGeom prst="rect">
             <a:avLst/>
@@ -7792,7 +7792,7 @@
         <p:spPr>
           <a:xfrm>
             <a:off x="612648" y="4069080"/>
-            <a:ext cx="5349240" cy="329184"/>
+            <a:ext cx="5257800" cy="329184"/>
           </a:xfrm>
           <a:prstGeom prst="rect">
             <a:avLst/>
@@ -7833,7 +7833,7 @@
         <p:spPr>
           <a:xfrm>
             <a:off x="502920" y="4526280"/>
-            <a:ext cx="2788920" cy="310896"/>
+            <a:ext cx="2697480" cy="310896"/>
           </a:xfrm>
           <a:prstGeom prst="rect">
             <a:avLst/>
@@ -7877,7 +7877,7 @@
         <p:spPr>
           <a:xfrm>
             <a:off x="576072" y="4526280"/>
-            <a:ext cx="2642616" cy="310896"/>
+            <a:ext cx="2551176" cy="310896"/>
           </a:xfrm>
           <a:prstGeom prst="rect">
             <a:avLst/>
@@ -7917,7 +7917,7 @@
         </p:nvSpPr>
         <p:spPr>
           <a:xfrm>
-            <a:off x="3291840" y="4526280"/>
+            <a:off x="3200400" y="4526280"/>
             <a:ext cx="1371600" cy="310896"/>
           </a:xfrm>
           <a:prstGeom prst="rect">
@@ -7961,7 +7961,7 @@
         </p:nvSpPr>
         <p:spPr>
           <a:xfrm>
-            <a:off x="3364992" y="4526280"/>
+            <a:off x="3273552" y="4526280"/>
             <a:ext cx="1225296" cy="310896"/>
           </a:xfrm>
           <a:prstGeom prst="rect">
@@ -8002,7 +8002,7 @@
         </p:nvSpPr>
         <p:spPr>
           <a:xfrm>
-            <a:off x="4663440" y="4526280"/>
+            <a:off x="4572000" y="4526280"/>
             <a:ext cx="1371600" cy="310896"/>
           </a:xfrm>
           <a:prstGeom prst="rect">
@@ -8046,7 +8046,7 @@
         </p:nvSpPr>
         <p:spPr>
           <a:xfrm>
-            <a:off x="4736592" y="4526280"/>
+            <a:off x="4645152" y="4526280"/>
             <a:ext cx="1225296" cy="310896"/>
           </a:xfrm>
           <a:prstGeom prst="rect">
@@ -8088,7 +8088,7 @@
         <p:spPr>
           <a:xfrm>
             <a:off x="502920" y="4837176"/>
-            <a:ext cx="2788920" cy="310896"/>
+            <a:ext cx="2697480" cy="310896"/>
           </a:xfrm>
           <a:prstGeom prst="rect">
             <a:avLst/>
@@ -8134,7 +8134,7 @@
         <p:spPr>
           <a:xfrm>
             <a:off x="576072" y="4837176"/>
-            <a:ext cx="2642616" cy="310896"/>
+            <a:ext cx="2551176" cy="310896"/>
           </a:xfrm>
           <a:prstGeom prst="rect">
             <a:avLst/>
@@ -8174,7 +8174,7 @@
         </p:nvSpPr>
         <p:spPr>
           <a:xfrm>
-            <a:off x="3291840" y="4837176"/>
+            <a:off x="3200400" y="4837176"/>
             <a:ext cx="1371600" cy="310896"/>
           </a:xfrm>
           <a:prstGeom prst="rect">
@@ -8220,7 +8220,7 @@
         </p:nvSpPr>
         <p:spPr>
           <a:xfrm>
-            <a:off x="3364992" y="4837176"/>
+            <a:off x="3273552" y="4837176"/>
             <a:ext cx="1225296" cy="310896"/>
           </a:xfrm>
           <a:prstGeom prst="rect">
@@ -8261,7 +8261,7 @@
         </p:nvSpPr>
         <p:spPr>
           <a:xfrm>
-            <a:off x="4663440" y="4837176"/>
+            <a:off x="4572000" y="4837176"/>
             <a:ext cx="1371600" cy="310896"/>
           </a:xfrm>
           <a:prstGeom prst="rect">
@@ -8307,7 +8307,7 @@
         </p:nvSpPr>
         <p:spPr>
           <a:xfrm>
-            <a:off x="4736592" y="4837176"/>
+            <a:off x="4645152" y="4837176"/>
             <a:ext cx="1225296" cy="310896"/>
           </a:xfrm>
           <a:prstGeom prst="rect">
@@ -8349,7 +8349,7 @@
         <p:spPr>
           <a:xfrm>
             <a:off x="502920" y="5148072"/>
-            <a:ext cx="2788920" cy="310896"/>
+            <a:ext cx="2697480" cy="310896"/>
           </a:xfrm>
           <a:prstGeom prst="rect">
             <a:avLst/>
@@ -8395,7 +8395,7 @@
         <p:spPr>
           <a:xfrm>
             <a:off x="576072" y="5148072"/>
-            <a:ext cx="2642616" cy="310896"/>
+            <a:ext cx="2551176" cy="310896"/>
           </a:xfrm>
           <a:prstGeom prst="rect">
             <a:avLst/>
@@ -8435,7 +8435,7 @@
         </p:nvSpPr>
         <p:spPr>
           <a:xfrm>
-            <a:off x="3291840" y="5148072"/>
+            <a:off x="3200400" y="5148072"/>
             <a:ext cx="1371600" cy="310896"/>
           </a:xfrm>
           <a:prstGeom prst="rect">
@@ -8481,7 +8481,7 @@
         </p:nvSpPr>
         <p:spPr>
           <a:xfrm>
-            <a:off x="3364992" y="5148072"/>
+            <a:off x="3273552" y="5148072"/>
             <a:ext cx="1225296" cy="310896"/>
           </a:xfrm>
           <a:prstGeom prst="rect">
@@ -8522,7 +8522,7 @@
         </p:nvSpPr>
         <p:spPr>
           <a:xfrm>
-            <a:off x="4663440" y="5148072"/>
+            <a:off x="4572000" y="5148072"/>
             <a:ext cx="1371600" cy="310896"/>
           </a:xfrm>
           <a:prstGeom prst="rect">
@@ -8568,7 +8568,7 @@
         </p:nvSpPr>
         <p:spPr>
           <a:xfrm>
-            <a:off x="4736592" y="5148072"/>
+            <a:off x="4645152" y="5148072"/>
             <a:ext cx="1225296" cy="310896"/>
           </a:xfrm>
           <a:prstGeom prst="rect">
@@ -8610,7 +8610,7 @@
         <p:spPr>
           <a:xfrm>
             <a:off x="502920" y="5568696"/>
-            <a:ext cx="5532120" cy="274320"/>
+            <a:ext cx="5440680" cy="274320"/>
           </a:xfrm>
           <a:prstGeom prst="rect">
             <a:avLst/>
@@ -8650,8 +8650,8 @@
         </p:nvSpPr>
         <p:spPr>
           <a:xfrm>
-            <a:off x="6355080" y="1325880"/>
-            <a:ext cx="5532120" cy="329184"/>
+            <a:off x="6245352" y="1325880"/>
+            <a:ext cx="5440680" cy="329184"/>
           </a:xfrm>
           <a:prstGeom prst="rect">
             <a:avLst/>
@@ -8694,8 +8694,8 @@
         </p:nvSpPr>
         <p:spPr>
           <a:xfrm>
-            <a:off x="6464808" y="1325880"/>
-            <a:ext cx="5349240" cy="329184"/>
+            <a:off x="6355080" y="1325880"/>
+            <a:ext cx="5257800" cy="329184"/>
           </a:xfrm>
           <a:prstGeom prst="rect">
             <a:avLst/>
@@ -8743,8 +8743,8 @@
         </p:blipFill>
         <p:spPr>
           <a:xfrm>
-            <a:off x="6355080" y="1783080"/>
-            <a:ext cx="2651760" cy="1751162"/>
+            <a:off x="6245352" y="1783080"/>
+            <a:ext cx="2606040" cy="1720970"/>
           </a:xfrm>
           <a:prstGeom prst="rect">
             <a:avLst/>
@@ -8767,8 +8767,8 @@
         </p:blipFill>
         <p:spPr>
           <a:xfrm>
-            <a:off x="9235440" y="1783080"/>
-            <a:ext cx="2651760" cy="1639977"/>
+            <a:off x="9079992" y="1783080"/>
+            <a:ext cx="2606040" cy="1611702"/>
           </a:xfrm>
           <a:prstGeom prst="rect">
             <a:avLst/>
@@ -8783,8 +8783,8 @@
         </p:nvSpPr>
         <p:spPr>
           <a:xfrm>
-            <a:off x="6355080" y="3566160"/>
-            <a:ext cx="2651760" cy="685800"/>
+            <a:off x="6245352" y="3566160"/>
+            <a:ext cx="2606040" cy="685800"/>
           </a:xfrm>
           <a:prstGeom prst="rect">
             <a:avLst/>
@@ -8842,8 +8842,8 @@
         </p:nvSpPr>
         <p:spPr>
           <a:xfrm>
-            <a:off x="9235440" y="3566160"/>
-            <a:ext cx="2651760" cy="685800"/>
+            <a:off x="9079992" y="3566160"/>
+            <a:ext cx="2606040" cy="685800"/>
           </a:xfrm>
           <a:prstGeom prst="rect">
             <a:avLst/>
@@ -8901,8 +8901,8 @@
         </p:nvSpPr>
         <p:spPr>
           <a:xfrm>
-            <a:off x="6355080" y="4480560"/>
-            <a:ext cx="5532120" cy="868680"/>
+            <a:off x="6245352" y="4480560"/>
+            <a:ext cx="5440680" cy="868680"/>
           </a:xfrm>
           <a:prstGeom prst="rect">
             <a:avLst/>
@@ -8945,8 +8945,8 @@
         </p:nvSpPr>
         <p:spPr>
           <a:xfrm>
-            <a:off x="6537960" y="4480560"/>
-            <a:ext cx="5166360" cy="868680"/>
+            <a:off x="6428232" y="4480560"/>
+            <a:ext cx="5074920" cy="868680"/>
           </a:xfrm>
           <a:prstGeom prst="rect">
             <a:avLst/>
@@ -9079,7 +9079,7 @@
                 <a:ea typeface="맑은 고딕"/>
                 <a:cs typeface="맑은 고딕"/>
               </a:rPr>
-              <a:t>Klüberbio AM 92-142  —  −60 °C 굴곡 스트립(Bending Strip) 시험</a:t>
+              <a:t>Klüberbio AM 92-142  —  -60 °C 굴곡 스트립(Bending Strip) 시험</a:t>
             </a:r>
           </a:p>
         </p:txBody>
@@ -9134,7 +9134,7 @@
         <p:spPr>
           <a:xfrm>
             <a:off x="502920" y="1325880"/>
-            <a:ext cx="5532120" cy="329184"/>
+            <a:ext cx="5440680" cy="329184"/>
           </a:xfrm>
           <a:prstGeom prst="rect">
             <a:avLst/>
@@ -9178,7 +9178,7 @@
         <p:spPr>
           <a:xfrm>
             <a:off x="612648" y="1325880"/>
-            <a:ext cx="5349240" cy="329184"/>
+            <a:ext cx="5257800" cy="329184"/>
           </a:xfrm>
           <a:prstGeom prst="rect">
             <a:avLst/>
@@ -9219,7 +9219,7 @@
         <p:spPr>
           <a:xfrm>
             <a:off x="502920" y="1783080"/>
-            <a:ext cx="5532120" cy="822960"/>
+            <a:ext cx="5440680" cy="822960"/>
           </a:xfrm>
           <a:prstGeom prst="rect">
             <a:avLst/>
@@ -9284,7 +9284,7 @@
         <p:spPr>
           <a:xfrm>
             <a:off x="502920" y="2743200"/>
-            <a:ext cx="5532120" cy="329184"/>
+            <a:ext cx="5440680" cy="329184"/>
           </a:xfrm>
           <a:prstGeom prst="rect">
             <a:avLst/>
@@ -9328,7 +9328,7 @@
         <p:spPr>
           <a:xfrm>
             <a:off x="612648" y="2743200"/>
-            <a:ext cx="5349240" cy="329184"/>
+            <a:ext cx="5257800" cy="329184"/>
           </a:xfrm>
           <a:prstGeom prst="rect">
             <a:avLst/>
@@ -9454,7 +9454,7 @@
         <p:spPr>
           <a:xfrm>
             <a:off x="1051560" y="3200400"/>
-            <a:ext cx="4983480" cy="384048"/>
+            <a:ext cx="4892040" cy="384048"/>
           </a:xfrm>
           <a:prstGeom prst="rect">
             <a:avLst/>
@@ -9580,7 +9580,7 @@
         <p:spPr>
           <a:xfrm>
             <a:off x="1051560" y="3675888"/>
-            <a:ext cx="4983480" cy="384048"/>
+            <a:ext cx="4892040" cy="384048"/>
           </a:xfrm>
           <a:prstGeom prst="rect">
             <a:avLst/>
@@ -9706,7 +9706,7 @@
         <p:spPr>
           <a:xfrm>
             <a:off x="1051560" y="4151376"/>
-            <a:ext cx="4983480" cy="384048"/>
+            <a:ext cx="4892040" cy="384048"/>
           </a:xfrm>
           <a:prstGeom prst="rect">
             <a:avLst/>
@@ -9747,7 +9747,7 @@
         <p:spPr>
           <a:xfrm>
             <a:off x="502920" y="4800600"/>
-            <a:ext cx="5532120" cy="777240"/>
+            <a:ext cx="5440680" cy="777240"/>
           </a:xfrm>
           <a:prstGeom prst="rect">
             <a:avLst/>
@@ -9791,7 +9791,7 @@
         <p:spPr>
           <a:xfrm>
             <a:off x="685800" y="4800600"/>
-            <a:ext cx="5166360" cy="777240"/>
+            <a:ext cx="5074920" cy="777240"/>
           </a:xfrm>
           <a:prstGeom prst="rect">
             <a:avLst/>
@@ -9835,7 +9835,7 @@
         <p:spPr>
           <a:xfrm>
             <a:off x="502920" y="5760720"/>
-            <a:ext cx="5532120" cy="365760"/>
+            <a:ext cx="5440680" cy="365760"/>
           </a:xfrm>
           <a:prstGeom prst="rect">
             <a:avLst/>
@@ -9862,7 +9862,7 @@
                 <a:ea typeface="맑은 고딕"/>
                 <a:cs typeface="맑은 고딕"/>
               </a:rPr>
-              <a:t>유동점(Pour Point)  −30 °C  —  저온 환경 운용에 유리</a:t>
+              <a:t>유동점(Pour Point)  -30 °C  —  저온 환경 운용에 유리</a:t>
             </a:r>
           </a:p>
         </p:txBody>
@@ -9875,8 +9875,8 @@
         </p:nvSpPr>
         <p:spPr>
           <a:xfrm>
-            <a:off x="6355080" y="1325880"/>
-            <a:ext cx="5532120" cy="329184"/>
+            <a:off x="6245352" y="1325880"/>
+            <a:ext cx="5440680" cy="329184"/>
           </a:xfrm>
           <a:prstGeom prst="rect">
             <a:avLst/>
@@ -9919,8 +9919,8 @@
         </p:nvSpPr>
         <p:spPr>
           <a:xfrm>
-            <a:off x="6464808" y="1325880"/>
-            <a:ext cx="5349240" cy="329184"/>
+            <a:off x="6355080" y="1325880"/>
+            <a:ext cx="5257800" cy="329184"/>
           </a:xfrm>
           <a:prstGeom prst="rect">
             <a:avLst/>
@@ -9947,7 +9947,7 @@
                 <a:ea typeface="맑은 고딕"/>
                 <a:cs typeface="맑은 고딕"/>
               </a:rPr>
-              <a:t>−60 °C 저온 굴곡 시험 결과</a:t>
+              <a:t>-60 °C 저온 굴곡 시험 결과</a:t>
             </a:r>
           </a:p>
         </p:txBody>
@@ -9968,8 +9968,8 @@
         </p:blipFill>
         <p:spPr>
           <a:xfrm>
-            <a:off x="6355080" y="1783080"/>
-            <a:ext cx="2651760" cy="1409519"/>
+            <a:off x="6245352" y="1783080"/>
+            <a:ext cx="2606040" cy="1385217"/>
           </a:xfrm>
           <a:prstGeom prst="rect">
             <a:avLst/>
@@ -9992,8 +9992,8 @@
         </p:blipFill>
         <p:spPr>
           <a:xfrm>
-            <a:off x="9235440" y="1783080"/>
-            <a:ext cx="2651760" cy="1409519"/>
+            <a:off x="9079992" y="1783080"/>
+            <a:ext cx="2606040" cy="1385217"/>
           </a:xfrm>
           <a:prstGeom prst="rect">
             <a:avLst/>
@@ -10008,8 +10008,8 @@
         </p:nvSpPr>
         <p:spPr>
           <a:xfrm>
-            <a:off x="6355080" y="3300984"/>
-            <a:ext cx="2651760" cy="685800"/>
+            <a:off x="6245352" y="3300984"/>
+            <a:ext cx="2606040" cy="685800"/>
           </a:xfrm>
           <a:prstGeom prst="rect">
             <a:avLst/>
@@ -10067,8 +10067,8 @@
         </p:nvSpPr>
         <p:spPr>
           <a:xfrm>
-            <a:off x="9235440" y="3300984"/>
-            <a:ext cx="2651760" cy="685800"/>
+            <a:off x="9079992" y="3300984"/>
+            <a:ext cx="2606040" cy="685800"/>
           </a:xfrm>
           <a:prstGeom prst="rect">
             <a:avLst/>
@@ -10126,8 +10126,8 @@
         </p:nvSpPr>
         <p:spPr>
           <a:xfrm>
-            <a:off x="6355080" y="4169664"/>
-            <a:ext cx="5532120" cy="914400"/>
+            <a:off x="6245352" y="4169664"/>
+            <a:ext cx="5440680" cy="914400"/>
           </a:xfrm>
           <a:prstGeom prst="rect">
             <a:avLst/>
@@ -10170,8 +10170,8 @@
         </p:nvSpPr>
         <p:spPr>
           <a:xfrm>
-            <a:off x="6537960" y="4169664"/>
-            <a:ext cx="5166360" cy="914400"/>
+            <a:off x="6428232" y="4169664"/>
+            <a:ext cx="5074920" cy="914400"/>
           </a:xfrm>
           <a:prstGeom prst="rect">
             <a:avLst/>
@@ -10201,7 +10201,7 @@
                 <a:ea typeface="맑은 고딕"/>
                 <a:cs typeface="맑은 고딕"/>
               </a:rPr>
-              <a:t>−60 °C 에서 24시간 냉각 후 굴곡을 주어도 피막이 갈라지거나 벗겨지지 않았습니다.</a:t>
+              <a:t>-60 °C 에서 24시간 냉각 후 굴곡을 주어도 피막이 갈라지거나 벗겨지지 않았습니다.</a:t>
             </a:r>
           </a:p>
         </p:txBody>

</xml_diff>